<commit_message>
Fix report facts against the knowledge base; make the 10.7 deck open in PowerPoint
- Report and slides: law details match ConceptDetails, quantities list dimension,
  "defines" example and "describes" targets come from the data, wave equation
  belongs to the time-varying field chapter, every graph node shows its chapter
- Report: roadmap deliverables no longer wrap mid-word, float pages pack to the top
- Deck rebuilt with the fixed skill (unique shape IDs, no shared tags)

Co-Authored-By: Claude Opus 5.5 <noreply@anthropic.com>
</commit_message>
<xml_diff>
--- a/reports/data-structure-report/电磁场AI知识图谱汇报-杨国炜-10.7.pptx
+++ b/reports/data-structure-report/电磁场AI知识图谱汇报-杨国炜-10.7.pptx
@@ -1017,7 +1017,7 @@
           <a:lstStyle/>
           <a:p>
             <a:r>
-              <a:t>这张图的节点和关系都取自当前整理的数据。从矢量分析的散度出发，经过静电场的高斯定律，到时变电磁场的麦克斯韦方程组，再推导出电磁波的波动方程。颜色表示知识点类型，虚线是无方向的关系。</a:t>
+              <a:t>这张图的节点和关系都取自当前整理的数据。从矢量分析的散度出发，经过静电场的高斯定律，到时变电磁场的麦克斯韦方程组，再推导出波动方程；散度还是恒定电流场中电流连续性方程的前置知识。颜色表示知识点类型，虚线是无方向的关系。</a:t>
             </a:r>
           </a:p>
         </p:txBody>
@@ -7583,7 +7583,7 @@
                           <a:latin typeface="微软雅黑"/>
                           <a:ea typeface="微软雅黑"/>
                         </a:rPr>
-                        <a:t>文字表述、物理意义、常见误解</a:t>
+                        <a:t>定义、核心要点、常见误解（同概念）</a:t>
                       </a:r>
                     </a:p>
                   </a:txBody>
@@ -7669,7 +7669,7 @@
                           <a:latin typeface="微软雅黑"/>
                           <a:ea typeface="微软雅黑"/>
                         </a:rPr>
-                        <a:t>符号、单位、标量或矢量</a:t>
+                        <a:t>符号、单位、量纲、标量或矢量</a:t>
                       </a:r>
                     </a:p>
                   </a:txBody>
@@ -10203,7 +10203,7 @@
                           <a:latin typeface="微软雅黑"/>
                           <a:ea typeface="微软雅黑"/>
                         </a:rPr>
-                        <a:t>定律或公式 → 现象</a:t>
+                        <a:t>定律或公式 → 现象或物理量</a:t>
                       </a:r>
                     </a:p>
                   </a:txBody>
@@ -11479,7 +11479,7 @@
         <p:spPr>
           <a:xfrm>
             <a:off x="1907334" y="2579049"/>
-            <a:ext cx="0" cy="671400"/>
+            <a:ext cx="0" cy="608400"/>
           </a:xfrm>
           <a:prstGeom prst="line">
             <a:avLst/>
@@ -11500,7 +11500,7 @@
         </p:nvSpPr>
         <p:spPr>
           <a:xfrm>
-            <a:off x="1697224" y="2803299"/>
+            <a:off x="1697224" y="2771799"/>
             <a:ext cx="420221" cy="222899"/>
           </a:xfrm>
           <a:prstGeom prst="rect">
@@ -11598,8 +11598,8 @@
         </p:nvCxnSpPr>
         <p:spPr>
           <a:xfrm>
-            <a:off x="1907334" y="3664449"/>
-            <a:ext cx="0" cy="734400"/>
+            <a:off x="1907334" y="3727449"/>
+            <a:ext cx="0" cy="671400"/>
           </a:xfrm>
           <a:prstGeom prst="line">
             <a:avLst/>
@@ -11620,7 +11620,7 @@
         </p:nvSpPr>
         <p:spPr>
           <a:xfrm>
-            <a:off x="1697224" y="3920199"/>
+            <a:off x="1697224" y="3951699"/>
             <a:ext cx="420221" cy="222899"/>
           </a:xfrm>
           <a:prstGeom prst="rect">
@@ -11877,7 +11877,7 @@
                 <a:latin typeface="微软雅黑"/>
                 <a:ea typeface="微软雅黑"/>
               </a:rPr>
-              <a:t>电磁波</a:t>
+              <a:t>时变电磁场</a:t>
             </a:r>
           </a:p>
         </p:txBody>
@@ -12115,12 +12115,12 @@
         </p:nvSpPr>
         <p:spPr>
           <a:xfrm>
-            <a:off x="1088089" y="3250449"/>
-            <a:ext cx="1638490" cy="414000"/>
+            <a:off x="1088089" y="3187449"/>
+            <a:ext cx="1638490" cy="540000"/>
           </a:xfrm>
           <a:prstGeom prst="roundRect">
             <a:avLst>
-              <a:gd name="adj" fmla="val 15304"/>
+              <a:gd name="adj" fmla="val 11733"/>
             </a:avLst>
           </a:prstGeom>
           <a:solidFill>
@@ -12148,6 +12148,19 @@
                 <a:ea typeface="微软雅黑"/>
               </a:rPr>
               <a:t>电流连续性方程</a:t>
+            </a:r>
+          </a:p>
+          <a:p>
+            <a:pPr algn="ctr"/>
+            <a:r>
+              <a:rPr sz="1300" b="0" lang="zh-CN" altLang="en-US">
+                <a:solidFill>
+                  <a:srgbClr val="64748B"/>
+                </a:solidFill>
+                <a:latin typeface="微软雅黑"/>
+                <a:ea typeface="微软雅黑"/>
+              </a:rPr>
+              <a:t>恒定电流场</a:t>
             </a:r>
           </a:p>
         </p:txBody>
@@ -18204,11 +18217,7 @@
         <p:nvGrpSpPr>
           <p:cNvPr id="8" name="组合 7"/>
           <p:cNvGrpSpPr/>
-          <p:nvPr>
-            <p:custDataLst>
-              <p:tags r:id="rId2"/>
-            </p:custDataLst>
-          </p:nvPr>
+          <p:nvPr/>
         </p:nvGrpSpPr>
         <p:grpSpPr>
           <a:xfrm>
@@ -18258,10 +18267,10 @@
             <p:nvPr/>
           </p:nvPicPr>
           <p:blipFill>
-            <a:blip r:embed="rId8">
+            <a:blip r:embed="rId2">
               <a:extLst>
                 <a:ext uri="{96DAC541-7B7A-43D3-8B79-37D633B846F1}">
-                  <asvg:svgBlip xmlns:asvg="http://schemas.microsoft.com/office/drawing/2016/SVG/main" r:embed="rId9"/>
+                  <asvg:svgBlip xmlns:asvg="http://schemas.microsoft.com/office/drawing/2016/SVG/main" r:embed="rId3"/>
                 </a:ext>
               </a:extLst>
             </a:blip>
@@ -18359,13 +18368,9 @@
       </p:grpSp>
       <p:sp>
         <p:nvSpPr>
-          <p:cNvPr id="15" name="目录 1"/>
+          <p:cNvPr id="16" name="目录 1"/>
           <p:cNvSpPr txBox="1"/>
-          <p:nvPr>
-            <p:custDataLst>
-              <p:tags r:id="rId3"/>
-            </p:custDataLst>
-          </p:nvPr>
+          <p:nvPr/>
         </p:nvSpPr>
         <p:spPr>
           <a:xfrm>
@@ -18399,13 +18404,9 @@
       </p:sp>
       <p:sp>
         <p:nvSpPr>
-          <p:cNvPr id="15" name="目录 2"/>
+          <p:cNvPr id="17" name="目录 2"/>
           <p:cNvSpPr txBox="1"/>
-          <p:nvPr>
-            <p:custDataLst>
-              <p:tags r:id="rId3"/>
-            </p:custDataLst>
-          </p:nvPr>
+          <p:nvPr/>
         </p:nvSpPr>
         <p:spPr>
           <a:xfrm>
@@ -18439,13 +18440,9 @@
       </p:sp>
       <p:sp>
         <p:nvSpPr>
-          <p:cNvPr id="15" name="目录 3"/>
+          <p:cNvPr id="18" name="目录 3"/>
           <p:cNvSpPr txBox="1"/>
-          <p:nvPr>
-            <p:custDataLst>
-              <p:tags r:id="rId3"/>
-            </p:custDataLst>
-          </p:nvPr>
+          <p:nvPr/>
         </p:nvSpPr>
         <p:spPr>
           <a:xfrm>
@@ -18479,13 +18476,9 @@
       </p:sp>
       <p:sp>
         <p:nvSpPr>
-          <p:cNvPr id="15" name="目录 4"/>
+          <p:cNvPr id="19" name="目录 4"/>
           <p:cNvSpPr txBox="1"/>
-          <p:nvPr>
-            <p:custDataLst>
-              <p:tags r:id="rId3"/>
-            </p:custDataLst>
-          </p:nvPr>
+          <p:nvPr/>
         </p:nvSpPr>
         <p:spPr>
           <a:xfrm>
@@ -18519,13 +18512,9 @@
       </p:sp>
       <p:sp>
         <p:nvSpPr>
-          <p:cNvPr id="15" name="目录 5"/>
+          <p:cNvPr id="20" name="目录 5"/>
           <p:cNvSpPr txBox="1"/>
-          <p:nvPr>
-            <p:custDataLst>
-              <p:tags r:id="rId3"/>
-            </p:custDataLst>
-          </p:nvPr>
+          <p:nvPr/>
         </p:nvSpPr>
         <p:spPr>
           <a:xfrm>
@@ -18559,13 +18548,9 @@
       </p:sp>
       <p:sp>
         <p:nvSpPr>
-          <p:cNvPr id="15" name="目录 6"/>
+          <p:cNvPr id="21" name="目录 6"/>
           <p:cNvSpPr txBox="1"/>
-          <p:nvPr>
-            <p:custDataLst>
-              <p:tags r:id="rId3"/>
-            </p:custDataLst>
-          </p:nvPr>
+          <p:nvPr/>
         </p:nvSpPr>
         <p:spPr>
           <a:xfrm>
@@ -21312,42 +21297,6 @@
     <a:masterClrMapping/>
   </p:clrMapOvr>
 </p:sld>
-</file>
-
-<file path=ppt/tags/tag1.xml><?xml version="1.0" encoding="utf-8"?>
-<p:tagLst xmlns:a="http://schemas.openxmlformats.org/drawingml/2006/main" xmlns:r="http://schemas.openxmlformats.org/officeDocument/2006/relationships" xmlns:p="http://schemas.openxmlformats.org/presentationml/2006/main">
-  <p:tag name="KSO_WM_DIAGRAM_VIRTUALLY_FRAME" val="{&quot;height&quot;:539.999842519685,&quot;left&quot;:0,&quot;top&quot;:1,&quot;width&quot;:917.0512598425197}"/>
-</p:tagLst>
-</file>
-
-<file path=ppt/tags/tag2.xml><?xml version="1.0" encoding="utf-8"?>
-<p:tagLst xmlns:a="http://schemas.openxmlformats.org/drawingml/2006/main" xmlns:r="http://schemas.openxmlformats.org/officeDocument/2006/relationships" xmlns:p="http://schemas.openxmlformats.org/presentationml/2006/main">
-  <p:tag name="KSO_WM_DIAGRAM_VIRTUALLY_FRAME" val="{&quot;height&quot;:539.999842519685,&quot;left&quot;:0,&quot;top&quot;:1,&quot;width&quot;:917.0512598425197}"/>
-</p:tagLst>
-</file>
-
-<file path=ppt/tags/tag3.xml><?xml version="1.0" encoding="utf-8"?>
-<p:tagLst xmlns:a="http://schemas.openxmlformats.org/drawingml/2006/main" xmlns:r="http://schemas.openxmlformats.org/officeDocument/2006/relationships" xmlns:p="http://schemas.openxmlformats.org/presentationml/2006/main">
-  <p:tag name="KSO_WM_DIAGRAM_VIRTUALLY_FRAME" val="{&quot;height&quot;:539.999842519685,&quot;left&quot;:0,&quot;top&quot;:1,&quot;width&quot;:917.0512598425197}"/>
-</p:tagLst>
-</file>
-
-<file path=ppt/tags/tag4.xml><?xml version="1.0" encoding="utf-8"?>
-<p:tagLst xmlns:a="http://schemas.openxmlformats.org/drawingml/2006/main" xmlns:r="http://schemas.openxmlformats.org/officeDocument/2006/relationships" xmlns:p="http://schemas.openxmlformats.org/presentationml/2006/main">
-  <p:tag name="KSO_WM_DIAGRAM_VIRTUALLY_FRAME" val="{&quot;height&quot;:539.999842519685,&quot;left&quot;:0,&quot;top&quot;:1,&quot;width&quot;:917.0512598425197}"/>
-</p:tagLst>
-</file>
-
-<file path=ppt/tags/tag5.xml><?xml version="1.0" encoding="utf-8"?>
-<p:tagLst xmlns:a="http://schemas.openxmlformats.org/drawingml/2006/main" xmlns:r="http://schemas.openxmlformats.org/officeDocument/2006/relationships" xmlns:p="http://schemas.openxmlformats.org/presentationml/2006/main">
-  <p:tag name="KSO_WM_DIAGRAM_VIRTUALLY_FRAME" val="{&quot;height&quot;:539.999842519685,&quot;left&quot;:0,&quot;top&quot;:1,&quot;width&quot;:917.0512598425197}"/>
-</p:tagLst>
-</file>
-
-<file path=ppt/tags/tag6.xml><?xml version="1.0" encoding="utf-8"?>
-<p:tagLst xmlns:a="http://schemas.openxmlformats.org/drawingml/2006/main" xmlns:r="http://schemas.openxmlformats.org/officeDocument/2006/relationships" xmlns:p="http://schemas.openxmlformats.org/presentationml/2006/main">
-  <p:tag name="KSO_WM_DIAGRAM_VIRTUALLY_FRAME" val="{&quot;height&quot;:539.999842519685,&quot;left&quot;:0,&quot;top&quot;:1,&quot;width&quot;:917.0512598425197}"/>
-</p:tagLst>
 </file>
 
 <file path=ppt/theme/theme1.xml><?xml version="1.0" encoding="utf-8"?>

</xml_diff>